<commit_message>
Update founders to Dhruv Chaniyara and Madhav Wadhwana
- About: the team section now lists the current co-founders, each with a
  LinkedIn link (new tab). Bios are optional; none are shown until
  supplied
- Organization JSON-LD lists them as founders with their LinkedIn
  profiles as sameAs
- Blog: posts previously bylined to the former founders are credited to
  "Crelix Team" (Organization in BlogPosting JSON-LD) rather than
  reassigned to people who didn't write them
- Pitch deck (data/Crelix-AI-Pitch.pptx), team slide: names, initials and
  roles updated; the former founders' role bios are replaced with each
  new founder's LinkedIn address

Co-Authored-By: Claude Opus 5.5 <noreply@anthropic.com>
Claude-Session: https://claude.ai/code/session_01NcH8NyiXRizavUMbbgWviC
</commit_message>
<xml_diff>
--- a/data/Crelix-AI-Pitch.pptx
+++ b/data/Crelix-AI-Pitch.pptx
@@ -10217,7 +10217,7 @@
                 </a:solidFill>
                 <a:latin typeface="SF Pro Display"/>
               </a:rPr>
-              <a:t>BV</a:t>
+              <a:t>DC</a:t>
             </a:r>
           </a:p>
         </p:txBody>
@@ -10256,7 +10256,7 @@
                 </a:solidFill>
                 <a:latin typeface="SF Pro Display"/>
               </a:rPr>
-              <a:t>Bhargav Vyas</a:t>
+              <a:t>Dhruv Chaniyara</a:t>
             </a:r>
           </a:p>
         </p:txBody>
@@ -10295,7 +10295,7 @@
                 </a:solidFill>
                 <a:latin typeface="SF Pro Text"/>
               </a:rPr>
-              <a:t>CO-FOUNDER &amp; CEO</a:t>
+              <a:t>CO-FOUNDER</a:t>
             </a:r>
           </a:p>
         </p:txBody>
@@ -10334,7 +10334,7 @@
                 </a:solidFill>
                 <a:latin typeface="SF Pro Text"/>
               </a:rPr>
-              <a:t>Product direction and go-to-market. The best launch tool ships and secures in the same motion.</a:t>
+              <a:t>linkedin.com/in/dhruv-chaniyara-b60aa2247</a:t>
             </a:r>
           </a:p>
         </p:txBody>
@@ -10485,7 +10485,7 @@
                 </a:solidFill>
                 <a:latin typeface="SF Pro Display"/>
               </a:rPr>
-              <a:t>MS</a:t>
+              <a:t>MW</a:t>
             </a:r>
           </a:p>
         </p:txBody>
@@ -10524,7 +10524,7 @@
                 </a:solidFill>
                 <a:latin typeface="SF Pro Display"/>
               </a:rPr>
-              <a:t>Meet Savaliya</a:t>
+              <a:t>Madhav Wadhwana</a:t>
             </a:r>
           </a:p>
         </p:txBody>
@@ -10563,7 +10563,7 @@
                 </a:solidFill>
                 <a:latin typeface="SF Pro Text"/>
               </a:rPr>
-              <a:t>CO-FOUNDER &amp; CTO</a:t>
+              <a:t>CO-FOUNDER</a:t>
             </a:r>
           </a:p>
         </p:txBody>
@@ -10602,7 +10602,7 @@
                 </a:solidFill>
                 <a:latin typeface="SF Pro Text"/>
               </a:rPr>
-              <a:t>Engineering and the agent orchestration behind Flow, Pentest, and Search.</a:t>
+              <a:t>linkedin.com/in/madhav-wadhwana</a:t>
             </a:r>
           </a:p>
         </p:txBody>

</xml_diff>